<commit_message>
Add name to solution presentation
</commit_message>
<xml_diff>
--- a/docs/solution_presentation.pptx
+++ b/docs/solution_presentation.pptx
@@ -1,25 +1,25 @@
 
 <file path=ppt/presentation.xml><?xml version="1.0" encoding="utf-8"?>
-<p:presentation xmlns:a="http://schemas.openxmlformats.org/drawingml/2006/main" xmlns:r="http://schemas.openxmlformats.org/officeDocument/2006/relationships" xmlns:p="http://schemas.openxmlformats.org/presentationml/2006/main" saveSubsetFonts="1" autoCompressPictures="0">
+<p:presentation xmlns:a="http://schemas.openxmlformats.org/drawingml/2006/main" xmlns:r="http://schemas.openxmlformats.org/officeDocument/2006/relationships" xmlns:p="http://schemas.openxmlformats.org/presentationml/2006/main" autoCompressPictures="0">
   <p:sldMasterIdLst>
     <p:sldMasterId id="2147483648" r:id="rId1"/>
   </p:sldMasterIdLst>
+  <p:notesMasterIdLst>
+    <p:notesMasterId r:id="rId4"/>
+  </p:notesMasterIdLst>
   <p:sldIdLst>
-    <p:sldId id="256" r:id="rId2"/>
-    <p:sldId id="257" r:id="rId3"/>
-    <p:sldId id="258" r:id="rId4"/>
-    <p:sldId id="259" r:id="rId5"/>
-    <p:sldId id="260" r:id="rId6"/>
-    <p:sldId id="261" r:id="rId7"/>
-    <p:sldId id="262" r:id="rId8"/>
-    <p:sldId id="263" r:id="rId9"/>
-    <p:sldId id="264" r:id="rId10"/>
-    <p:sldId id="265" r:id="rId11"/>
-    <p:sldId id="266" r:id="rId12"/>
+    <p:sldId id="256" r:id="rId3"/>
+    <p:sldId id="257" r:id="rId5"/>
+    <p:sldId id="258" r:id="rId6"/>
+    <p:sldId id="259" r:id="rId7"/>
+    <p:sldId id="260" r:id="rId8"/>
+    <p:sldId id="261" r:id="rId9"/>
+    <p:sldId id="262" r:id="rId10"/>
+    <p:sldId id="263" r:id="rId11"/>
+    <p:sldId id="264" r:id="rId12"/>
+    <p:sldId id="265" r:id="rId13"/>
+    <p:sldId id="266" r:id="rId14"/>
   </p:sldIdLst>
-  <p:notesMasterIdLst>
-    <p:notesMasterId r:id="rId13"/>
-  </p:notesMasterIdLst>
   <p:sldSz cx="12192000" cy="6858000"/>
   <p:notesSz cx="6858000" cy="12192000"/>
   <p:defaultTextStyle>
@@ -199,7 +199,6 @@
           <a:p>
             <a:fld id="{5282F153-3F37-0F45-9E97-73ACFA13230C}" type="datetimeFigureOut">
               <a:rPr lang="en-US"/>
-              <a:t>7/23/19</a:t>
             </a:fld>
             <a:endParaRPr lang="en-US"/>
           </a:p>
@@ -266,6 +265,7 @@
               <a:rPr lang="en-US"/>
               <a:t>Click to edit Master text styles</a:t>
             </a:r>
+            <a:endParaRPr lang="en-US"/>
           </a:p>
           <a:p>
             <a:pPr lvl="1"/>
@@ -273,6 +273,7 @@
               <a:rPr lang="en-US"/>
               <a:t>Second level</a:t>
             </a:r>
+            <a:endParaRPr lang="en-US"/>
           </a:p>
           <a:p>
             <a:pPr lvl="2"/>
@@ -280,6 +281,7 @@
               <a:rPr lang="en-US"/>
               <a:t>Third level</a:t>
             </a:r>
+            <a:endParaRPr lang="en-US"/>
           </a:p>
           <a:p>
             <a:pPr lvl="3"/>
@@ -287,6 +289,7 @@
               <a:rPr lang="en-US"/>
               <a:t>Fourth level</a:t>
             </a:r>
+            <a:endParaRPr lang="en-US"/>
           </a:p>
           <a:p>
             <a:pPr lvl="4"/>
@@ -294,6 +297,7 @@
               <a:rPr lang="en-US"/>
               <a:t>Fifth level</a:t>
             </a:r>
+            <a:endParaRPr lang="en-US"/>
           </a:p>
         </p:txBody>
       </p:sp>
@@ -357,18 +361,12 @@
           <a:p>
             <a:fld id="{CE5E9CC1-C706-0F49-92D6-E571CC5EEA8F}" type="slidenum">
               <a:rPr lang="en-US"/>
-              <a:t>‹#›</a:t>
             </a:fld>
             <a:endParaRPr lang="en-US"/>
           </a:p>
         </p:txBody>
       </p:sp>
     </p:spTree>
-    <p:extLst>
-      <p:ext uri="{BB962C8B-B14F-4D97-AF65-F5344CB8AC3E}">
-        <p14:creationId xmlns:p14="http://schemas.microsoft.com/office/powerpoint/2010/main" val="1024086991"/>
-      </p:ext>
-    </p:extLst>
   </p:cSld>
   <p:clrMap bg1="lt1" tx1="dk1" bg2="lt2" tx2="dk2" accent1="accent1" accent2="accent2" accent3="accent3" accent4="accent4" accent5="accent5" accent6="accent6" hlink="hlink" folHlink="folHlink"/>
   <p:notesStyle>
@@ -510,10 +508,6 @@
           <a:bodyPr/>
           <a:lstStyle/>
           <a:p>
-            <a:r>
-              <a:rPr lang="en-US" dirty="0"/>
-              <a:t/>
-            </a:r>
             <a:endParaRPr lang="en-US" dirty="0"/>
           </a:p>
         </p:txBody>
@@ -535,18 +529,12 @@
           <a:p>
             <a:fld id="{F7021451-1387-4CA6-816F-3879F97B5CBC}" type="slidenum">
               <a:rPr lang="en-US"/>
-              <a:t>1</a:t>
             </a:fld>
             <a:endParaRPr lang="en-US"/>
           </a:p>
         </p:txBody>
       </p:sp>
     </p:spTree>
-    <p:extLst>
-      <p:ext uri="{BB962C8B-B14F-4D97-AF65-F5344CB8AC3E}">
-        <p14:creationId xmlns:p14="http://schemas.microsoft.com/office/powerpoint/2010/main" val="1024086991"/>
-      </p:ext>
-    </p:extLst>
   </p:cSld>
   <p:clrMapOvr>
     <a:masterClrMapping/>
@@ -598,10 +586,6 @@
           <a:bodyPr/>
           <a:lstStyle/>
           <a:p>
-            <a:r>
-              <a:rPr lang="en-US" dirty="0"/>
-              <a:t/>
-            </a:r>
             <a:endParaRPr lang="en-US" dirty="0"/>
           </a:p>
         </p:txBody>
@@ -623,18 +607,12 @@
           <a:p>
             <a:fld id="{F7021451-1387-4CA6-816F-3879F97B5CBC}" type="slidenum">
               <a:rPr lang="en-US"/>
-              <a:t>10</a:t>
             </a:fld>
             <a:endParaRPr lang="en-US"/>
           </a:p>
         </p:txBody>
       </p:sp>
     </p:spTree>
-    <p:extLst>
-      <p:ext uri="{BB962C8B-B14F-4D97-AF65-F5344CB8AC3E}">
-        <p14:creationId xmlns:p14="http://schemas.microsoft.com/office/powerpoint/2010/main" val="1024086991"/>
-      </p:ext>
-    </p:extLst>
   </p:cSld>
   <p:clrMapOvr>
     <a:masterClrMapping/>
@@ -686,10 +664,6 @@
           <a:bodyPr/>
           <a:lstStyle/>
           <a:p>
-            <a:r>
-              <a:rPr lang="en-US" dirty="0"/>
-              <a:t/>
-            </a:r>
             <a:endParaRPr lang="en-US" dirty="0"/>
           </a:p>
         </p:txBody>
@@ -711,18 +685,12 @@
           <a:p>
             <a:fld id="{F7021451-1387-4CA6-816F-3879F97B5CBC}" type="slidenum">
               <a:rPr lang="en-US"/>
-              <a:t>11</a:t>
             </a:fld>
             <a:endParaRPr lang="en-US"/>
           </a:p>
         </p:txBody>
       </p:sp>
     </p:spTree>
-    <p:extLst>
-      <p:ext uri="{BB962C8B-B14F-4D97-AF65-F5344CB8AC3E}">
-        <p14:creationId xmlns:p14="http://schemas.microsoft.com/office/powerpoint/2010/main" val="1024086991"/>
-      </p:ext>
-    </p:extLst>
   </p:cSld>
   <p:clrMapOvr>
     <a:masterClrMapping/>
@@ -774,10 +742,6 @@
           <a:bodyPr/>
           <a:lstStyle/>
           <a:p>
-            <a:r>
-              <a:rPr lang="en-US" dirty="0"/>
-              <a:t/>
-            </a:r>
             <a:endParaRPr lang="en-US" dirty="0"/>
           </a:p>
         </p:txBody>
@@ -799,18 +763,12 @@
           <a:p>
             <a:fld id="{F7021451-1387-4CA6-816F-3879F97B5CBC}" type="slidenum">
               <a:rPr lang="en-US"/>
-              <a:t>2</a:t>
             </a:fld>
             <a:endParaRPr lang="en-US"/>
           </a:p>
         </p:txBody>
       </p:sp>
     </p:spTree>
-    <p:extLst>
-      <p:ext uri="{BB962C8B-B14F-4D97-AF65-F5344CB8AC3E}">
-        <p14:creationId xmlns:p14="http://schemas.microsoft.com/office/powerpoint/2010/main" val="1024086991"/>
-      </p:ext>
-    </p:extLst>
   </p:cSld>
   <p:clrMapOvr>
     <a:masterClrMapping/>
@@ -862,10 +820,6 @@
           <a:bodyPr/>
           <a:lstStyle/>
           <a:p>
-            <a:r>
-              <a:rPr lang="en-US" dirty="0"/>
-              <a:t/>
-            </a:r>
             <a:endParaRPr lang="en-US" dirty="0"/>
           </a:p>
         </p:txBody>
@@ -887,18 +841,12 @@
           <a:p>
             <a:fld id="{F7021451-1387-4CA6-816F-3879F97B5CBC}" type="slidenum">
               <a:rPr lang="en-US"/>
-              <a:t>3</a:t>
             </a:fld>
             <a:endParaRPr lang="en-US"/>
           </a:p>
         </p:txBody>
       </p:sp>
     </p:spTree>
-    <p:extLst>
-      <p:ext uri="{BB962C8B-B14F-4D97-AF65-F5344CB8AC3E}">
-        <p14:creationId xmlns:p14="http://schemas.microsoft.com/office/powerpoint/2010/main" val="1024086991"/>
-      </p:ext>
-    </p:extLst>
   </p:cSld>
   <p:clrMapOvr>
     <a:masterClrMapping/>
@@ -950,10 +898,6 @@
           <a:bodyPr/>
           <a:lstStyle/>
           <a:p>
-            <a:r>
-              <a:rPr lang="en-US" dirty="0"/>
-              <a:t/>
-            </a:r>
             <a:endParaRPr lang="en-US" dirty="0"/>
           </a:p>
         </p:txBody>
@@ -975,18 +919,12 @@
           <a:p>
             <a:fld id="{F7021451-1387-4CA6-816F-3879F97B5CBC}" type="slidenum">
               <a:rPr lang="en-US"/>
-              <a:t>4</a:t>
             </a:fld>
             <a:endParaRPr lang="en-US"/>
           </a:p>
         </p:txBody>
       </p:sp>
     </p:spTree>
-    <p:extLst>
-      <p:ext uri="{BB962C8B-B14F-4D97-AF65-F5344CB8AC3E}">
-        <p14:creationId xmlns:p14="http://schemas.microsoft.com/office/powerpoint/2010/main" val="1024086991"/>
-      </p:ext>
-    </p:extLst>
   </p:cSld>
   <p:clrMapOvr>
     <a:masterClrMapping/>
@@ -1038,10 +976,6 @@
           <a:bodyPr/>
           <a:lstStyle/>
           <a:p>
-            <a:r>
-              <a:rPr lang="en-US" dirty="0"/>
-              <a:t/>
-            </a:r>
             <a:endParaRPr lang="en-US" dirty="0"/>
           </a:p>
         </p:txBody>
@@ -1063,18 +997,12 @@
           <a:p>
             <a:fld id="{F7021451-1387-4CA6-816F-3879F97B5CBC}" type="slidenum">
               <a:rPr lang="en-US"/>
-              <a:t>5</a:t>
             </a:fld>
             <a:endParaRPr lang="en-US"/>
           </a:p>
         </p:txBody>
       </p:sp>
     </p:spTree>
-    <p:extLst>
-      <p:ext uri="{BB962C8B-B14F-4D97-AF65-F5344CB8AC3E}">
-        <p14:creationId xmlns:p14="http://schemas.microsoft.com/office/powerpoint/2010/main" val="1024086991"/>
-      </p:ext>
-    </p:extLst>
   </p:cSld>
   <p:clrMapOvr>
     <a:masterClrMapping/>
@@ -1126,10 +1054,6 @@
           <a:bodyPr/>
           <a:lstStyle/>
           <a:p>
-            <a:r>
-              <a:rPr lang="en-US" dirty="0"/>
-              <a:t/>
-            </a:r>
             <a:endParaRPr lang="en-US" dirty="0"/>
           </a:p>
         </p:txBody>
@@ -1151,18 +1075,12 @@
           <a:p>
             <a:fld id="{F7021451-1387-4CA6-816F-3879F97B5CBC}" type="slidenum">
               <a:rPr lang="en-US"/>
-              <a:t>6</a:t>
             </a:fld>
             <a:endParaRPr lang="en-US"/>
           </a:p>
         </p:txBody>
       </p:sp>
     </p:spTree>
-    <p:extLst>
-      <p:ext uri="{BB962C8B-B14F-4D97-AF65-F5344CB8AC3E}">
-        <p14:creationId xmlns:p14="http://schemas.microsoft.com/office/powerpoint/2010/main" val="1024086991"/>
-      </p:ext>
-    </p:extLst>
   </p:cSld>
   <p:clrMapOvr>
     <a:masterClrMapping/>
@@ -1214,10 +1132,6 @@
           <a:bodyPr/>
           <a:lstStyle/>
           <a:p>
-            <a:r>
-              <a:rPr lang="en-US" dirty="0"/>
-              <a:t/>
-            </a:r>
             <a:endParaRPr lang="en-US" dirty="0"/>
           </a:p>
         </p:txBody>
@@ -1239,18 +1153,12 @@
           <a:p>
             <a:fld id="{F7021451-1387-4CA6-816F-3879F97B5CBC}" type="slidenum">
               <a:rPr lang="en-US"/>
-              <a:t>7</a:t>
             </a:fld>
             <a:endParaRPr lang="en-US"/>
           </a:p>
         </p:txBody>
       </p:sp>
     </p:spTree>
-    <p:extLst>
-      <p:ext uri="{BB962C8B-B14F-4D97-AF65-F5344CB8AC3E}">
-        <p14:creationId xmlns:p14="http://schemas.microsoft.com/office/powerpoint/2010/main" val="1024086991"/>
-      </p:ext>
-    </p:extLst>
   </p:cSld>
   <p:clrMapOvr>
     <a:masterClrMapping/>
@@ -1302,10 +1210,6 @@
           <a:bodyPr/>
           <a:lstStyle/>
           <a:p>
-            <a:r>
-              <a:rPr lang="en-US" dirty="0"/>
-              <a:t/>
-            </a:r>
             <a:endParaRPr lang="en-US" dirty="0"/>
           </a:p>
         </p:txBody>
@@ -1327,18 +1231,12 @@
           <a:p>
             <a:fld id="{F7021451-1387-4CA6-816F-3879F97B5CBC}" type="slidenum">
               <a:rPr lang="en-US"/>
-              <a:t>8</a:t>
             </a:fld>
             <a:endParaRPr lang="en-US"/>
           </a:p>
         </p:txBody>
       </p:sp>
     </p:spTree>
-    <p:extLst>
-      <p:ext uri="{BB962C8B-B14F-4D97-AF65-F5344CB8AC3E}">
-        <p14:creationId xmlns:p14="http://schemas.microsoft.com/office/powerpoint/2010/main" val="1024086991"/>
-      </p:ext>
-    </p:extLst>
   </p:cSld>
   <p:clrMapOvr>
     <a:masterClrMapping/>
@@ -1390,10 +1288,6 @@
           <a:bodyPr/>
           <a:lstStyle/>
           <a:p>
-            <a:r>
-              <a:rPr lang="en-US" dirty="0"/>
-              <a:t/>
-            </a:r>
             <a:endParaRPr lang="en-US" dirty="0"/>
           </a:p>
         </p:txBody>
@@ -1415,18 +1309,12 @@
           <a:p>
             <a:fld id="{F7021451-1387-4CA6-816F-3879F97B5CBC}" type="slidenum">
               <a:rPr lang="en-US"/>
-              <a:t>9</a:t>
             </a:fld>
             <a:endParaRPr lang="en-US"/>
           </a:p>
         </p:txBody>
       </p:sp>
     </p:spTree>
-    <p:extLst>
-      <p:ext uri="{BB962C8B-B14F-4D97-AF65-F5344CB8AC3E}">
-        <p14:creationId xmlns:p14="http://schemas.microsoft.com/office/powerpoint/2010/main" val="1024086991"/>
-      </p:ext>
-    </p:extLst>
   </p:cSld>
   <p:clrMapOvr>
     <a:masterClrMapping/>
@@ -1467,6 +1355,11 @@
 <file path=ppt/slideMasters/slideMaster1.xml><?xml version="1.0" encoding="utf-8"?>
 <p:sldMaster xmlns:a="http://schemas.openxmlformats.org/drawingml/2006/main" xmlns:r="http://schemas.openxmlformats.org/officeDocument/2006/relationships" xmlns:p="http://schemas.openxmlformats.org/presentationml/2006/main">
   <p:cSld>
+    <p:bg>
+      <p:bgRef idx="1001">
+        <a:schemeClr val="bg1"/>
+      </p:bgRef>
+    </p:bg>
     <p:spTree>
       <p:nvGrpSpPr>
         <p:cNvPr id="1" name=""/>
@@ -1510,7 +1403,7 @@
         <a:spcBef>
           <a:spcPct val="20000"/>
         </a:spcBef>
-        <a:buFont typeface="Arial" pitchFamily="34" charset="0"/>
+        <a:buFont typeface="Arial" panose="020B0704020202020204" pitchFamily="34" charset="0"/>
         <a:buChar char="•"/>
         <a:defRPr sz="3200" kern="1200">
           <a:solidFill>
@@ -1525,7 +1418,7 @@
         <a:spcBef>
           <a:spcPct val="20000"/>
         </a:spcBef>
-        <a:buFont typeface="Arial" pitchFamily="34" charset="0"/>
+        <a:buFont typeface="Arial" panose="020B0704020202020204" pitchFamily="34" charset="0"/>
         <a:buChar char="–"/>
         <a:defRPr sz="2800" kern="1200">
           <a:solidFill>
@@ -1540,7 +1433,7 @@
         <a:spcBef>
           <a:spcPct val="20000"/>
         </a:spcBef>
-        <a:buFont typeface="Arial" pitchFamily="34" charset="0"/>
+        <a:buFont typeface="Arial" panose="020B0704020202020204" pitchFamily="34" charset="0"/>
         <a:buChar char="•"/>
         <a:defRPr sz="2400" kern="1200">
           <a:solidFill>
@@ -1555,7 +1448,7 @@
         <a:spcBef>
           <a:spcPct val="20000"/>
         </a:spcBef>
-        <a:buFont typeface="Arial" pitchFamily="34" charset="0"/>
+        <a:buFont typeface="Arial" panose="020B0704020202020204" pitchFamily="34" charset="0"/>
         <a:buChar char="–"/>
         <a:defRPr sz="2000" kern="1200">
           <a:solidFill>
@@ -1570,7 +1463,7 @@
         <a:spcBef>
           <a:spcPct val="20000"/>
         </a:spcBef>
-        <a:buFont typeface="Arial" pitchFamily="34" charset="0"/>
+        <a:buFont typeface="Arial" panose="020B0704020202020204" pitchFamily="34" charset="0"/>
         <a:buChar char="»"/>
         <a:defRPr sz="2000" kern="1200">
           <a:solidFill>
@@ -1585,7 +1478,7 @@
         <a:spcBef>
           <a:spcPct val="20000"/>
         </a:spcBef>
-        <a:buFont typeface="Arial" pitchFamily="34" charset="0"/>
+        <a:buFont typeface="Arial" panose="020B0704020202020204" pitchFamily="34" charset="0"/>
         <a:buChar char="•"/>
         <a:defRPr sz="2000" kern="1200">
           <a:solidFill>
@@ -1600,7 +1493,7 @@
         <a:spcBef>
           <a:spcPct val="20000"/>
         </a:spcBef>
-        <a:buFont typeface="Arial" pitchFamily="34" charset="0"/>
+        <a:buFont typeface="Arial" panose="020B0704020202020204" pitchFamily="34" charset="0"/>
         <a:buChar char="•"/>
         <a:defRPr sz="2000" kern="1200">
           <a:solidFill>
@@ -1615,7 +1508,7 @@
         <a:spcBef>
           <a:spcPct val="20000"/>
         </a:spcBef>
-        <a:buFont typeface="Arial" pitchFamily="34" charset="0"/>
+        <a:buFont typeface="Arial" panose="020B0704020202020204" pitchFamily="34" charset="0"/>
         <a:buChar char="•"/>
         <a:defRPr sz="2000" kern="1200">
           <a:solidFill>
@@ -1630,7 +1523,7 @@
         <a:spcBef>
           <a:spcPct val="20000"/>
         </a:spcBef>
-        <a:buFont typeface="Arial" pitchFamily="34" charset="0"/>
+        <a:buFont typeface="Arial" panose="020B0704020202020204" pitchFamily="34" charset="0"/>
         <a:buChar char="•"/>
         <a:defRPr sz="2000" kern="1200">
           <a:solidFill>
@@ -1743,12 +1636,13 @@
 
 <file path=ppt/slides/slide1.xml><?xml version="1.0" encoding="utf-8"?>
 <p:sld xmlns:a="http://schemas.openxmlformats.org/drawingml/2006/main" xmlns:r="http://schemas.openxmlformats.org/officeDocument/2006/relationships" xmlns:p="http://schemas.openxmlformats.org/presentationml/2006/main">
-  <p:cSld name="Slide 1">
+  <p:cSld>
     <p:bg>
       <p:bgPr>
         <a:solidFill>
           <a:srgbClr val="0F172A"/>
         </a:solidFill>
+        <a:effectLst/>
       </p:bgPr>
     </p:bg>
     <p:spTree>
@@ -1780,13 +1674,12 @@
             <a:avLst/>
           </a:prstGeom>
           <a:noFill/>
-          <a:ln/>
         </p:spPr>
         <p:txBody>
           <a:bodyPr wrap="square" rtlCol="0" anchor="ctr"/>
           <a:lstStyle/>
           <a:p>
-            <a:pPr algn="l" indent="0" marL="0">
+            <a:pPr marL="0" indent="0" algn="l">
               <a:buNone/>
             </a:pPr>
             <a:r>
@@ -1800,7 +1693,7 @@
             <a:endParaRPr lang="en-US" sz="3400" dirty="0"/>
           </a:p>
           <a:p>
-            <a:pPr algn="l" indent="0" marL="0">
+            <a:pPr marL="0" indent="0" algn="l">
               <a:buNone/>
             </a:pPr>
             <a:r>
@@ -1830,13 +1723,12 @@
             <a:avLst/>
           </a:prstGeom>
           <a:noFill/>
-          <a:ln/>
         </p:spPr>
         <p:txBody>
           <a:bodyPr wrap="square" rtlCol="0" anchor="ctr"/>
           <a:lstStyle/>
           <a:p>
-            <a:pPr indent="0" marL="0">
+            <a:pPr marL="0" indent="0">
               <a:buNone/>
             </a:pPr>
             <a:r>
@@ -1859,20 +1751,19 @@
         </p:nvSpPr>
         <p:spPr>
           <a:xfrm>
-            <a:off x="731520" y="6126480"/>
+            <a:off x="751840" y="6126480"/>
             <a:ext cx="9144000" cy="365760"/>
           </a:xfrm>
           <a:prstGeom prst="rect">
             <a:avLst/>
           </a:prstGeom>
           <a:noFill/>
-          <a:ln/>
         </p:spPr>
         <p:txBody>
           <a:bodyPr wrap="square" rtlCol="0" anchor="ctr"/>
           <a:lstStyle/>
           <a:p>
-            <a:pPr indent="0" marL="0">
+            <a:pPr marL="0" indent="0">
               <a:buNone/>
             </a:pPr>
             <a:r>
@@ -1881,7 +1772,7 @@
                   <a:srgbClr val="94A3B8"/>
                 </a:solidFill>
               </a:rPr>
-              <a:t>Candidate: [Your Name]   |   Submission date: [Date]</a:t>
+              <a:t>Candidate: Kamali</a:t>
             </a:r>
             <a:endParaRPr lang="en-US" sz="1200" dirty="0"/>
           </a:p>
@@ -1897,12 +1788,13 @@
 
 <file path=ppt/slides/slide10.xml><?xml version="1.0" encoding="utf-8"?>
 <p:sld xmlns:a="http://schemas.openxmlformats.org/drawingml/2006/main" xmlns:r="http://schemas.openxmlformats.org/officeDocument/2006/relationships" xmlns:p="http://schemas.openxmlformats.org/presentationml/2006/main">
-  <p:cSld name="Slide 10">
+  <p:cSld>
     <p:bg>
       <p:bgPr>
         <a:solidFill>
           <a:srgbClr val="FFFFFF"/>
         </a:solidFill>
+        <a:effectLst/>
       </p:bgPr>
     </p:bg>
     <p:spTree>
@@ -1934,13 +1826,12 @@
             <a:avLst/>
           </a:prstGeom>
           <a:noFill/>
-          <a:ln/>
         </p:spPr>
         <p:txBody>
           <a:bodyPr wrap="square" rtlCol="0" anchor="ctr"/>
           <a:lstStyle/>
           <a:p>
-            <a:pPr indent="0" marL="0">
+            <a:pPr marL="0" indent="0">
               <a:buNone/>
             </a:pPr>
             <a:r>
@@ -1970,7 +1861,6 @@
             <a:avLst/>
           </a:prstGeom>
           <a:noFill/>
-          <a:ln/>
         </p:spPr>
         <p:txBody>
           <a:bodyPr wrap="square" rtlCol="0" anchor="t"/>
@@ -2077,12 +1967,13 @@
 
 <file path=ppt/slides/slide11.xml><?xml version="1.0" encoding="utf-8"?>
 <p:sld xmlns:a="http://schemas.openxmlformats.org/drawingml/2006/main" xmlns:r="http://schemas.openxmlformats.org/officeDocument/2006/relationships" xmlns:p="http://schemas.openxmlformats.org/presentationml/2006/main">
-  <p:cSld name="Slide 11">
+  <p:cSld>
     <p:bg>
       <p:bgPr>
         <a:solidFill>
           <a:srgbClr val="FFFFFF"/>
         </a:solidFill>
+        <a:effectLst/>
       </p:bgPr>
     </p:bg>
     <p:spTree>
@@ -2114,13 +2005,12 @@
             <a:avLst/>
           </a:prstGeom>
           <a:noFill/>
-          <a:ln/>
         </p:spPr>
         <p:txBody>
           <a:bodyPr wrap="square" rtlCol="0" anchor="ctr"/>
           <a:lstStyle/>
           <a:p>
-            <a:pPr indent="0" marL="0">
+            <a:pPr marL="0" indent="0">
               <a:buNone/>
             </a:pPr>
             <a:r>
@@ -2150,7 +2040,6 @@
             <a:avLst/>
           </a:prstGeom>
           <a:noFill/>
-          <a:ln/>
         </p:spPr>
         <p:txBody>
           <a:bodyPr wrap="square" rtlCol="0" anchor="t"/>
@@ -2239,12 +2128,13 @@
 
 <file path=ppt/slides/slide2.xml><?xml version="1.0" encoding="utf-8"?>
 <p:sld xmlns:a="http://schemas.openxmlformats.org/drawingml/2006/main" xmlns:r="http://schemas.openxmlformats.org/officeDocument/2006/relationships" xmlns:p="http://schemas.openxmlformats.org/presentationml/2006/main">
-  <p:cSld name="Slide 2">
+  <p:cSld>
     <p:bg>
       <p:bgPr>
         <a:solidFill>
           <a:srgbClr val="FFFFFF"/>
         </a:solidFill>
+        <a:effectLst/>
       </p:bgPr>
     </p:bg>
     <p:spTree>
@@ -2276,13 +2166,12 @@
             <a:avLst/>
           </a:prstGeom>
           <a:noFill/>
-          <a:ln/>
         </p:spPr>
         <p:txBody>
           <a:bodyPr wrap="square" rtlCol="0" anchor="ctr"/>
           <a:lstStyle/>
           <a:p>
-            <a:pPr indent="0" marL="0">
+            <a:pPr marL="0" indent="0">
               <a:buNone/>
             </a:pPr>
             <a:r>
@@ -2312,7 +2201,6 @@
             <a:avLst/>
           </a:prstGeom>
           <a:noFill/>
-          <a:ln/>
         </p:spPr>
         <p:txBody>
           <a:bodyPr wrap="square" rtlCol="0" anchor="t"/>
@@ -2401,12 +2289,13 @@
 
 <file path=ppt/slides/slide3.xml><?xml version="1.0" encoding="utf-8"?>
 <p:sld xmlns:a="http://schemas.openxmlformats.org/drawingml/2006/main" xmlns:r="http://schemas.openxmlformats.org/officeDocument/2006/relationships" xmlns:p="http://schemas.openxmlformats.org/presentationml/2006/main">
-  <p:cSld name="Slide 3">
+  <p:cSld>
     <p:bg>
       <p:bgPr>
         <a:solidFill>
           <a:srgbClr val="FFFFFF"/>
         </a:solidFill>
+        <a:effectLst/>
       </p:bgPr>
     </p:bg>
     <p:spTree>
@@ -2438,13 +2327,12 @@
             <a:avLst/>
           </a:prstGeom>
           <a:noFill/>
-          <a:ln/>
         </p:spPr>
         <p:txBody>
           <a:bodyPr wrap="square" rtlCol="0" anchor="ctr"/>
           <a:lstStyle/>
           <a:p>
-            <a:pPr indent="0" marL="0">
+            <a:pPr marL="0" indent="0">
               <a:buNone/>
             </a:pPr>
             <a:r>
@@ -2461,7 +2349,7 @@
       </p:sp>
       <p:pic>
         <p:nvPicPr>
-          <p:cNvPr id="3" name="Image 0" descr="/home/claude/project-root/docs/architecture.png">    </p:cNvPr>
+          <p:cNvPr id="3" name="Image 0" descr="/home/claude/project-root/docs/architecture.png"/>
           <p:cNvPicPr>
             <a:picLocks noChangeAspect="1"/>
           </p:cNvPicPr>
@@ -2498,13 +2386,12 @@
             <a:avLst/>
           </a:prstGeom>
           <a:noFill/>
-          <a:ln/>
         </p:spPr>
         <p:txBody>
           <a:bodyPr wrap="square" rtlCol="0" anchor="t"/>
           <a:lstStyle/>
           <a:p>
-            <a:pPr indent="0" marL="0">
+            <a:pPr marL="0" indent="0">
               <a:buNone/>
             </a:pPr>
             <a:r>
@@ -2518,7 +2405,7 @@
             <a:endParaRPr lang="en-US" sz="1300" dirty="0"/>
           </a:p>
           <a:p>
-            <a:pPr indent="0" marL="0">
+            <a:pPr marL="0" indent="0">
               <a:spcAft>
                 <a:spcPts val="1000"/>
               </a:spcAft>
@@ -2535,7 +2422,7 @@
             <a:endParaRPr lang="en-US" sz="1300" dirty="0"/>
           </a:p>
           <a:p>
-            <a:pPr indent="0" marL="0">
+            <a:pPr marL="0" indent="0">
               <a:spcAft>
                 <a:spcPts val="1000"/>
               </a:spcAft>
@@ -2552,7 +2439,7 @@
             <a:endParaRPr lang="en-US" sz="1300" dirty="0"/>
           </a:p>
           <a:p>
-            <a:pPr indent="0" marL="0">
+            <a:pPr marL="0" indent="0">
               <a:buNone/>
             </a:pPr>
             <a:r>
@@ -2577,12 +2464,13 @@
 
 <file path=ppt/slides/slide4.xml><?xml version="1.0" encoding="utf-8"?>
 <p:sld xmlns:a="http://schemas.openxmlformats.org/drawingml/2006/main" xmlns:r="http://schemas.openxmlformats.org/officeDocument/2006/relationships" xmlns:p="http://schemas.openxmlformats.org/presentationml/2006/main">
-  <p:cSld name="Slide 4">
+  <p:cSld>
     <p:bg>
       <p:bgPr>
         <a:solidFill>
           <a:srgbClr val="FFFFFF"/>
         </a:solidFill>
+        <a:effectLst/>
       </p:bgPr>
     </p:bg>
     <p:spTree>
@@ -2614,13 +2502,12 @@
             <a:avLst/>
           </a:prstGeom>
           <a:noFill/>
-          <a:ln/>
         </p:spPr>
         <p:txBody>
           <a:bodyPr wrap="square" rtlCol="0" anchor="ctr"/>
           <a:lstStyle/>
           <a:p>
-            <a:pPr indent="0" marL="0">
+            <a:pPr marL="0" indent="0">
               <a:buNone/>
             </a:pPr>
             <a:r>
@@ -2650,7 +2537,6 @@
             <a:avLst/>
           </a:prstGeom>
           <a:noFill/>
-          <a:ln/>
         </p:spPr>
         <p:txBody>
           <a:bodyPr wrap="square" rtlCol="0" anchor="t"/>
@@ -2757,12 +2643,13 @@
 
 <file path=ppt/slides/slide5.xml><?xml version="1.0" encoding="utf-8"?>
 <p:sld xmlns:a="http://schemas.openxmlformats.org/drawingml/2006/main" xmlns:r="http://schemas.openxmlformats.org/officeDocument/2006/relationships" xmlns:p="http://schemas.openxmlformats.org/presentationml/2006/main">
-  <p:cSld name="Slide 5">
+  <p:cSld>
     <p:bg>
       <p:bgPr>
         <a:solidFill>
           <a:srgbClr val="FFFFFF"/>
         </a:solidFill>
+        <a:effectLst/>
       </p:bgPr>
     </p:bg>
     <p:spTree>
@@ -2794,13 +2681,12 @@
             <a:avLst/>
           </a:prstGeom>
           <a:noFill/>
-          <a:ln/>
         </p:spPr>
         <p:txBody>
           <a:bodyPr wrap="square" rtlCol="0" anchor="ctr"/>
           <a:lstStyle/>
           <a:p>
-            <a:pPr indent="0" marL="0">
+            <a:pPr marL="0" indent="0">
               <a:buNone/>
             </a:pPr>
             <a:r>
@@ -2830,7 +2716,6 @@
             <a:avLst/>
           </a:prstGeom>
           <a:noFill/>
-          <a:ln/>
         </p:spPr>
         <p:txBody>
           <a:bodyPr wrap="square" rtlCol="0" anchor="t"/>
@@ -2937,12 +2822,13 @@
 
 <file path=ppt/slides/slide6.xml><?xml version="1.0" encoding="utf-8"?>
 <p:sld xmlns:a="http://schemas.openxmlformats.org/drawingml/2006/main" xmlns:r="http://schemas.openxmlformats.org/officeDocument/2006/relationships" xmlns:p="http://schemas.openxmlformats.org/presentationml/2006/main">
-  <p:cSld name="Slide 6">
+  <p:cSld>
     <p:bg>
       <p:bgPr>
         <a:solidFill>
           <a:srgbClr val="FFFFFF"/>
         </a:solidFill>
+        <a:effectLst/>
       </p:bgPr>
     </p:bg>
     <p:spTree>
@@ -2974,13 +2860,12 @@
             <a:avLst/>
           </a:prstGeom>
           <a:noFill/>
-          <a:ln/>
         </p:spPr>
         <p:txBody>
           <a:bodyPr wrap="square" rtlCol="0" anchor="ctr"/>
           <a:lstStyle/>
           <a:p>
-            <a:pPr indent="0" marL="0">
+            <a:pPr marL="0" indent="0">
               <a:buNone/>
             </a:pPr>
             <a:r>
@@ -3010,7 +2895,6 @@
             <a:avLst/>
           </a:prstGeom>
           <a:noFill/>
-          <a:ln/>
         </p:spPr>
         <p:txBody>
           <a:bodyPr wrap="square" rtlCol="0" anchor="t"/>
@@ -3135,12 +3019,13 @@
 
 <file path=ppt/slides/slide7.xml><?xml version="1.0" encoding="utf-8"?>
 <p:sld xmlns:a="http://schemas.openxmlformats.org/drawingml/2006/main" xmlns:r="http://schemas.openxmlformats.org/officeDocument/2006/relationships" xmlns:p="http://schemas.openxmlformats.org/presentationml/2006/main">
-  <p:cSld name="Slide 7">
+  <p:cSld>
     <p:bg>
       <p:bgPr>
         <a:solidFill>
           <a:srgbClr val="FFFFFF"/>
         </a:solidFill>
+        <a:effectLst/>
       </p:bgPr>
     </p:bg>
     <p:spTree>
@@ -3172,13 +3057,12 @@
             <a:avLst/>
           </a:prstGeom>
           <a:noFill/>
-          <a:ln/>
         </p:spPr>
         <p:txBody>
           <a:bodyPr wrap="square" rtlCol="0" anchor="ctr"/>
           <a:lstStyle/>
           <a:p>
-            <a:pPr indent="0" marL="0">
+            <a:pPr marL="0" indent="0">
               <a:buNone/>
             </a:pPr>
             <a:r>
@@ -3208,7 +3092,6 @@
             <a:avLst/>
           </a:prstGeom>
           <a:noFill/>
-          <a:ln/>
         </p:spPr>
         <p:txBody>
           <a:bodyPr wrap="square" rtlCol="0" anchor="t"/>
@@ -3315,12 +3198,13 @@
 
 <file path=ppt/slides/slide8.xml><?xml version="1.0" encoding="utf-8"?>
 <p:sld xmlns:a="http://schemas.openxmlformats.org/drawingml/2006/main" xmlns:r="http://schemas.openxmlformats.org/officeDocument/2006/relationships" xmlns:p="http://schemas.openxmlformats.org/presentationml/2006/main">
-  <p:cSld name="Slide 8">
+  <p:cSld>
     <p:bg>
       <p:bgPr>
         <a:solidFill>
           <a:srgbClr val="FFFFFF"/>
         </a:solidFill>
+        <a:effectLst/>
       </p:bgPr>
     </p:bg>
     <p:spTree>
@@ -3352,13 +3236,12 @@
             <a:avLst/>
           </a:prstGeom>
           <a:noFill/>
-          <a:ln/>
         </p:spPr>
         <p:txBody>
           <a:bodyPr wrap="square" rtlCol="0" anchor="ctr"/>
           <a:lstStyle/>
           <a:p>
-            <a:pPr indent="0" marL="0">
+            <a:pPr marL="0" indent="0">
               <a:buNone/>
             </a:pPr>
             <a:r>
@@ -3388,7 +3271,6 @@
             <a:avLst/>
           </a:prstGeom>
           <a:noFill/>
-          <a:ln/>
         </p:spPr>
         <p:txBody>
           <a:bodyPr wrap="square" rtlCol="0" anchor="t"/>
@@ -3477,12 +3359,13 @@
 
 <file path=ppt/slides/slide9.xml><?xml version="1.0" encoding="utf-8"?>
 <p:sld xmlns:a="http://schemas.openxmlformats.org/drawingml/2006/main" xmlns:r="http://schemas.openxmlformats.org/officeDocument/2006/relationships" xmlns:p="http://schemas.openxmlformats.org/presentationml/2006/main">
-  <p:cSld name="Slide 9">
+  <p:cSld>
     <p:bg>
       <p:bgPr>
         <a:solidFill>
           <a:srgbClr val="FFFFFF"/>
         </a:solidFill>
+        <a:effectLst/>
       </p:bgPr>
     </p:bg>
     <p:spTree>
@@ -3514,13 +3397,12 @@
             <a:avLst/>
           </a:prstGeom>
           <a:noFill/>
-          <a:ln/>
         </p:spPr>
         <p:txBody>
           <a:bodyPr wrap="square" rtlCol="0" anchor="ctr"/>
           <a:lstStyle/>
           <a:p>
-            <a:pPr indent="0" marL="0">
+            <a:pPr marL="0" indent="0">
               <a:buNone/>
             </a:pPr>
             <a:r>
@@ -3550,7 +3432,6 @@
             <a:avLst/>
           </a:prstGeom>
           <a:noFill/>
-          <a:ln/>
         </p:spPr>
         <p:txBody>
           <a:bodyPr wrap="square" rtlCol="0" anchor="t"/>
@@ -3698,7 +3579,7 @@
     </a:clrScheme>
     <a:fontScheme name="Office">
       <a:majorFont>
-        <a:latin typeface="Calibri Light" panose="020F0302020204030204"/>
+        <a:latin typeface="Calibri Light"/>
         <a:ea typeface=""/>
         <a:cs typeface=""/>
         <a:font script="Jpan" typeface="游ゴシック Light"/>
@@ -3731,26 +3612,9 @@
         <a:font script="Viet" typeface="Times New Roman"/>
         <a:font script="Uigh" typeface="Microsoft Uighur"/>
         <a:font script="Geor" typeface="Sylfaen"/>
-        <a:font script="Armn" typeface="Arial"/>
-        <a:font script="Bugi" typeface="Leelawadee UI"/>
-        <a:font script="Bopo" typeface="Microsoft JhengHei"/>
-        <a:font script="Java" typeface="Javanese Text"/>
-        <a:font script="Lisu" typeface="Segoe UI"/>
-        <a:font script="Mymr" typeface="Myanmar Text"/>
-        <a:font script="Nkoo" typeface="Ebrima"/>
-        <a:font script="Olck" typeface="Nirmala UI"/>
-        <a:font script="Osma" typeface="Ebrima"/>
-        <a:font script="Phag" typeface="Phagspa"/>
-        <a:font script="Syrn" typeface="Estrangelo Edessa"/>
-        <a:font script="Syrj" typeface="Estrangelo Edessa"/>
-        <a:font script="Syre" typeface="Estrangelo Edessa"/>
-        <a:font script="Sora" typeface="Nirmala UI"/>
-        <a:font script="Tale" typeface="Microsoft Tai Le"/>
-        <a:font script="Talu" typeface="Microsoft New Tai Lue"/>
-        <a:font script="Tfng" typeface="Ebrima"/>
       </a:majorFont>
       <a:minorFont>
-        <a:latin typeface="Calibri" panose="020F0502020204030204"/>
+        <a:latin typeface="Calibri"/>
         <a:ea typeface=""/>
         <a:cs typeface=""/>
         <a:font script="Jpan" typeface="游ゴシック"/>
@@ -3783,23 +3647,6 @@
         <a:font script="Viet" typeface="Arial"/>
         <a:font script="Uigh" typeface="Microsoft Uighur"/>
         <a:font script="Geor" typeface="Sylfaen"/>
-        <a:font script="Armn" typeface="Arial"/>
-        <a:font script="Bugi" typeface="Leelawadee UI"/>
-        <a:font script="Bopo" typeface="Microsoft JhengHei"/>
-        <a:font script="Java" typeface="Javanese Text"/>
-        <a:font script="Lisu" typeface="Segoe UI"/>
-        <a:font script="Mymr" typeface="Myanmar Text"/>
-        <a:font script="Nkoo" typeface="Ebrima"/>
-        <a:font script="Olck" typeface="Nirmala UI"/>
-        <a:font script="Osma" typeface="Ebrima"/>
-        <a:font script="Phag" typeface="Phagspa"/>
-        <a:font script="Syrn" typeface="Estrangelo Edessa"/>
-        <a:font script="Syrj" typeface="Estrangelo Edessa"/>
-        <a:font script="Syre" typeface="Estrangelo Edessa"/>
-        <a:font script="Sora" typeface="Nirmala UI"/>
-        <a:font script="Tale" typeface="Microsoft Tai Le"/>
-        <a:font script="Talu" typeface="Microsoft New Tai Lue"/>
-        <a:font script="Tfng" typeface="Ebrima"/>
       </a:minorFont>
     </a:fontScheme>
     <a:fmtScheme name="Office">
@@ -3940,8 +3787,265 @@
       </a:bgFillStyleLst>
     </a:fmtScheme>
   </a:themeElements>
-  <a:objectDefaults/>
-  <a:extraClrSchemeLst/>
+  <a:extLst>
+    <a:ext uri="{05A4C25C-085E-4340-85A3-A5531E510DB2}">
+      <thm15:themeFamily xmlns:thm15="http://schemas.microsoft.com/office/thememl/2012/main" name="Office Theme" id="{62F939B6-93AF-4DB8-9C6B-D6C7DFDC589F}" vid="{4A3C46E8-61CC-4603-A589-7422A47A8E4A}"/>
+    </a:ext>
+  </a:extLst>
+</a:theme>
+</file>
+
+<file path=ppt/theme/theme2.xml><?xml version="1.0" encoding="utf-8"?>
+<a:theme xmlns:a="http://schemas.openxmlformats.org/drawingml/2006/main" name="Office Theme">
+  <a:themeElements>
+    <a:clrScheme name="Office">
+      <a:dk1>
+        <a:sysClr val="windowText" lastClr="000000"/>
+      </a:dk1>
+      <a:lt1>
+        <a:sysClr val="window" lastClr="FFFFFF"/>
+      </a:lt1>
+      <a:dk2>
+        <a:srgbClr val="44546A"/>
+      </a:dk2>
+      <a:lt2>
+        <a:srgbClr val="E7E6E6"/>
+      </a:lt2>
+      <a:accent1>
+        <a:srgbClr val="4472C4"/>
+      </a:accent1>
+      <a:accent2>
+        <a:srgbClr val="ED7D31"/>
+      </a:accent2>
+      <a:accent3>
+        <a:srgbClr val="A5A5A5"/>
+      </a:accent3>
+      <a:accent4>
+        <a:srgbClr val="FFC000"/>
+      </a:accent4>
+      <a:accent5>
+        <a:srgbClr val="5B9BD5"/>
+      </a:accent5>
+      <a:accent6>
+        <a:srgbClr val="70AD47"/>
+      </a:accent6>
+      <a:hlink>
+        <a:srgbClr val="0563C1"/>
+      </a:hlink>
+      <a:folHlink>
+        <a:srgbClr val="954F72"/>
+      </a:folHlink>
+    </a:clrScheme>
+    <a:fontScheme name="Office">
+      <a:majorFont>
+        <a:latin typeface="Calibri Light"/>
+        <a:ea typeface=""/>
+        <a:cs typeface=""/>
+        <a:font script="Jpan" typeface="游ゴシック Light"/>
+        <a:font script="Hang" typeface="맑은 고딕"/>
+        <a:font script="Hans" typeface="等线 Light"/>
+        <a:font script="Hant" typeface="新細明體"/>
+        <a:font script="Arab" typeface="Times New Roman"/>
+        <a:font script="Hebr" typeface="Times New Roman"/>
+        <a:font script="Thai" typeface="Angsana New"/>
+        <a:font script="Ethi" typeface="Nyala"/>
+        <a:font script="Beng" typeface="Vrinda"/>
+        <a:font script="Gujr" typeface="Shruti"/>
+        <a:font script="Khmr" typeface="MoolBoran"/>
+        <a:font script="Knda" typeface="Tunga"/>
+        <a:font script="Guru" typeface="Raavi"/>
+        <a:font script="Cans" typeface="Euphemia"/>
+        <a:font script="Cher" typeface="Plantagenet Cherokee"/>
+        <a:font script="Yiii" typeface="Microsoft Yi Baiti"/>
+        <a:font script="Tibt" typeface="Microsoft Himalaya"/>
+        <a:font script="Thaa" typeface="MV Boli"/>
+        <a:font script="Deva" typeface="Mangal"/>
+        <a:font script="Telu" typeface="Gautami"/>
+        <a:font script="Taml" typeface="Latha"/>
+        <a:font script="Syrc" typeface="Estrangelo Edessa"/>
+        <a:font script="Orya" typeface="Kalinga"/>
+        <a:font script="Mlym" typeface="Kartika"/>
+        <a:font script="Laoo" typeface="DokChampa"/>
+        <a:font script="Sinh" typeface="Iskoola Pota"/>
+        <a:font script="Mong" typeface="Mongolian Baiti"/>
+        <a:font script="Viet" typeface="Times New Roman"/>
+        <a:font script="Uigh" typeface="Microsoft Uighur"/>
+        <a:font script="Geor" typeface="Sylfaen"/>
+      </a:majorFont>
+      <a:minorFont>
+        <a:latin typeface="Calibri"/>
+        <a:ea typeface=""/>
+        <a:cs typeface=""/>
+        <a:font script="Jpan" typeface="游ゴシック"/>
+        <a:font script="Hang" typeface="맑은 고딕"/>
+        <a:font script="Hans" typeface="等线"/>
+        <a:font script="Hant" typeface="新細明體"/>
+        <a:font script="Arab" typeface="Arial"/>
+        <a:font script="Hebr" typeface="Arial"/>
+        <a:font script="Thai" typeface="Cordia New"/>
+        <a:font script="Ethi" typeface="Nyala"/>
+        <a:font script="Beng" typeface="Vrinda"/>
+        <a:font script="Gujr" typeface="Shruti"/>
+        <a:font script="Khmr" typeface="DaunPenh"/>
+        <a:font script="Knda" typeface="Tunga"/>
+        <a:font script="Guru" typeface="Raavi"/>
+        <a:font script="Cans" typeface="Euphemia"/>
+        <a:font script="Cher" typeface="Plantagenet Cherokee"/>
+        <a:font script="Yiii" typeface="Microsoft Yi Baiti"/>
+        <a:font script="Tibt" typeface="Microsoft Himalaya"/>
+        <a:font script="Thaa" typeface="MV Boli"/>
+        <a:font script="Deva" typeface="Mangal"/>
+        <a:font script="Telu" typeface="Gautami"/>
+        <a:font script="Taml" typeface="Latha"/>
+        <a:font script="Syrc" typeface="Estrangelo Edessa"/>
+        <a:font script="Orya" typeface="Kalinga"/>
+        <a:font script="Mlym" typeface="Kartika"/>
+        <a:font script="Laoo" typeface="DokChampa"/>
+        <a:font script="Sinh" typeface="Iskoola Pota"/>
+        <a:font script="Mong" typeface="Mongolian Baiti"/>
+        <a:font script="Viet" typeface="Arial"/>
+        <a:font script="Uigh" typeface="Microsoft Uighur"/>
+        <a:font script="Geor" typeface="Sylfaen"/>
+      </a:minorFont>
+    </a:fontScheme>
+    <a:fmtScheme name="Office">
+      <a:fillStyleLst>
+        <a:solidFill>
+          <a:schemeClr val="phClr"/>
+        </a:solidFill>
+        <a:gradFill rotWithShape="1">
+          <a:gsLst>
+            <a:gs pos="0">
+              <a:schemeClr val="phClr">
+                <a:lumMod val="110000"/>
+                <a:satMod val="105000"/>
+                <a:tint val="67000"/>
+              </a:schemeClr>
+            </a:gs>
+            <a:gs pos="50000">
+              <a:schemeClr val="phClr">
+                <a:lumMod val="105000"/>
+                <a:satMod val="103000"/>
+                <a:tint val="73000"/>
+              </a:schemeClr>
+            </a:gs>
+            <a:gs pos="100000">
+              <a:schemeClr val="phClr">
+                <a:lumMod val="105000"/>
+                <a:satMod val="109000"/>
+                <a:tint val="81000"/>
+              </a:schemeClr>
+            </a:gs>
+          </a:gsLst>
+          <a:lin ang="5400000" scaled="0"/>
+        </a:gradFill>
+        <a:gradFill rotWithShape="1">
+          <a:gsLst>
+            <a:gs pos="0">
+              <a:schemeClr val="phClr">
+                <a:satMod val="103000"/>
+                <a:lumMod val="102000"/>
+                <a:tint val="94000"/>
+              </a:schemeClr>
+            </a:gs>
+            <a:gs pos="50000">
+              <a:schemeClr val="phClr">
+                <a:satMod val="110000"/>
+                <a:lumMod val="100000"/>
+                <a:shade val="100000"/>
+              </a:schemeClr>
+            </a:gs>
+            <a:gs pos="100000">
+              <a:schemeClr val="phClr">
+                <a:lumMod val="99000"/>
+                <a:satMod val="120000"/>
+                <a:shade val="78000"/>
+              </a:schemeClr>
+            </a:gs>
+          </a:gsLst>
+          <a:lin ang="5400000" scaled="0"/>
+        </a:gradFill>
+      </a:fillStyleLst>
+      <a:lnStyleLst>
+        <a:ln w="6350" cap="flat" cmpd="sng" algn="ctr">
+          <a:solidFill>
+            <a:schemeClr val="phClr"/>
+          </a:solidFill>
+          <a:prstDash val="solid"/>
+          <a:miter lim="800000"/>
+        </a:ln>
+        <a:ln w="12700" cap="flat" cmpd="sng" algn="ctr">
+          <a:solidFill>
+            <a:schemeClr val="phClr"/>
+          </a:solidFill>
+          <a:prstDash val="solid"/>
+          <a:miter lim="800000"/>
+        </a:ln>
+        <a:ln w="19050" cap="flat" cmpd="sng" algn="ctr">
+          <a:solidFill>
+            <a:schemeClr val="phClr"/>
+          </a:solidFill>
+          <a:prstDash val="solid"/>
+          <a:miter lim="800000"/>
+        </a:ln>
+      </a:lnStyleLst>
+      <a:effectStyleLst>
+        <a:effectStyle>
+          <a:effectLst/>
+        </a:effectStyle>
+        <a:effectStyle>
+          <a:effectLst/>
+        </a:effectStyle>
+        <a:effectStyle>
+          <a:effectLst>
+            <a:outerShdw blurRad="57150" dist="19050" dir="5400000" algn="ctr" rotWithShape="0">
+              <a:srgbClr val="000000">
+                <a:alpha val="63000"/>
+              </a:srgbClr>
+            </a:outerShdw>
+          </a:effectLst>
+        </a:effectStyle>
+      </a:effectStyleLst>
+      <a:bgFillStyleLst>
+        <a:solidFill>
+          <a:schemeClr val="phClr"/>
+        </a:solidFill>
+        <a:solidFill>
+          <a:schemeClr val="phClr">
+            <a:tint val="95000"/>
+            <a:satMod val="170000"/>
+          </a:schemeClr>
+        </a:solidFill>
+        <a:gradFill rotWithShape="1">
+          <a:gsLst>
+            <a:gs pos="0">
+              <a:schemeClr val="phClr">
+                <a:tint val="93000"/>
+                <a:satMod val="150000"/>
+                <a:shade val="98000"/>
+                <a:lumMod val="102000"/>
+              </a:schemeClr>
+            </a:gs>
+            <a:gs pos="50000">
+              <a:schemeClr val="phClr">
+                <a:tint val="98000"/>
+                <a:satMod val="130000"/>
+                <a:shade val="90000"/>
+                <a:lumMod val="103000"/>
+              </a:schemeClr>
+            </a:gs>
+            <a:gs pos="100000">
+              <a:schemeClr val="phClr">
+                <a:shade val="63000"/>
+                <a:satMod val="120000"/>
+              </a:schemeClr>
+            </a:gs>
+          </a:gsLst>
+          <a:lin ang="5400000" scaled="0"/>
+        </a:gradFill>
+      </a:bgFillStyleLst>
+    </a:fmtScheme>
+  </a:themeElements>
   <a:extLst>
     <a:ext uri="{05A4C25C-085E-4340-85A3-A5531E510DB2}">
       <thm15:themeFamily xmlns:thm15="http://schemas.microsoft.com/office/thememl/2012/main" name="Office Theme" id="{62F939B6-93AF-4DB8-9C6B-D6C7DFDC589F}" vid="{4A3C46E8-61CC-4603-A589-7422A47A8E4A}"/>

</xml_diff>